<commit_message>
Semester 1 Week 04: learning path, notebook explanations, slide and sheet fixes
- README: ordered learning path with PDF pages, prerequisites, outcomes,
  answers table, staff notes (corrections, PowerPoint re-export, MATLAB alpha)
- 7 notebooks, text and comments only: opening cell, explanation above each
  code cell, constraint comments, What do you notice / Try it with answers;
  no code or printed result changed
- lecture .pptx: diet constraints (14x5, 10x9), alpha < 1/6 (was 0.17),
  at least / at most, ratio heading, Q6a numbering, typos
- Slack Variables .pptx: P = 5*0 + 4*0; <= / >= wording
- tutorial/answers .docx: at least / at most, typos, course-site link,
  slack wording, Q1b results table

Co-Authored-By: Claude Opus 5.5 <noreply@anthropic.com>
Claude-Session: https://claude.ai/code/session_01MvNKmqjaG26DoWDSRmZHTm

[skip ci]
</commit_message>
<xml_diff>
--- a/content/Lectures/Semester 1/Week 04 - Mathematical Programming - Modelling/5 Source Files/Slack Variables.pptx
+++ b/content/Lectures/Semester 1/Week 04 - Mathematical Programming - Modelling/5 Source Files/Slack Variables.pptx
@@ -3808,7 +3808,7 @@
               <a:p>
                 <a:r>
                   <a:rPr lang="en-GB" dirty="0"/>
-                  <a:t>Used for less than </a:t>
+                  <a:t>Used for ≤ (less than or equal to) constraints</a:t>
                 </a:r>
               </a:p>
               <a:p>
@@ -4029,7 +4029,7 @@
               <a:p>
                 <a:r>
                   <a:rPr lang="en-GB" dirty="0"/>
-                  <a:t>Used for greater than</a:t>
+                  <a:t>Used for ≥ (greater than or equal to) constraints</a:t>
                 </a:r>
               </a:p>
               <a:p>
@@ -4805,7 +4805,7 @@
                         <a:rPr lang="en-GB" sz="2400" b="0" i="1" smtClean="0">
                           <a:latin typeface="Cambria Math" panose="02040503050406030204" pitchFamily="18" charset="0"/>
                         </a:rPr>
-                        <m:t>=5⋅0+7⋅0=0</m:t>
+                        <m:t>=5⋅0+4⋅0=0</m:t>
                       </m:r>
                     </m:oMath>
                   </m:oMathPara>

</xml_diff>